<commit_message>
Added changes at 2025-02-19
</commit_message>
<xml_diff>
--- a/RL/02 - Deep Reinforcement Learning/02 - 05 PG-PPO/Presentation/PPO.pptx
+++ b/RL/02 - Deep Reinforcement Learning/02 - 05 PG-PPO/Presentation/PPO.pptx
@@ -14244,8 +14244,8 @@
           </a:p>
         </p:txBody>
       </p:sp>
-      <mc:AlternateContent xmlns:mc="http://schemas.openxmlformats.org/markup-compatibility/2006">
-        <mc:Choice xmlns:a14="http://schemas.microsoft.com/office/drawing/2010/main" Requires="a14">
+      <mc:AlternateContent xmlns:mc="http://schemas.openxmlformats.org/markup-compatibility/2006" xmlns:a14="http://schemas.microsoft.com/office/drawing/2010/main">
+        <mc:Choice Requires="a14">
           <p:sp>
             <p:nvSpPr>
               <p:cNvPr id="3" name="Text Placeholder 2">
@@ -14615,7 +14615,7 @@
             </p:txBody>
           </p:sp>
         </mc:Choice>
-        <mc:Fallback>
+        <mc:Fallback xmlns="">
           <p:sp>
             <p:nvSpPr>
               <p:cNvPr id="3" name="Text Placeholder 2">
@@ -20759,7 +20759,7 @@
         <p:spPr>
           <a:xfrm>
             <a:off x="1654525" y="2049300"/>
-            <a:ext cx="2475300" cy="877200"/>
+            <a:ext cx="2475300" cy="646300"/>
           </a:xfrm>
           <a:prstGeom prst="rect">
             <a:avLst/>
@@ -20817,78 +20817,7 @@
                 <a:cs typeface="Roboto"/>
                 <a:sym typeface="Roboto"/>
               </a:rPr>
-              <a:t>в учебной группе </a:t>
-            </a:r>
-            <a:endParaRPr sz="1500" dirty="0">
-              <a:latin typeface="Roboto"/>
-              <a:ea typeface="Roboto"/>
-              <a:cs typeface="Roboto"/>
-              <a:sym typeface="Roboto"/>
-            </a:endParaRPr>
-          </a:p>
-          <a:p>
-            <a:pPr marL="0" lvl="0" indent="0" algn="l" rtl="0">
-              <a:spcBef>
-                <a:spcPts val="0"/>
-              </a:spcBef>
-              <a:spcAft>
-                <a:spcPts val="0"/>
-              </a:spcAft>
-              <a:buNone/>
-            </a:pPr>
-            <a:r>
-              <a:rPr lang="ru" sz="1500" dirty="0">
-                <a:latin typeface="Roboto"/>
-                <a:ea typeface="Roboto"/>
-                <a:cs typeface="Roboto"/>
-                <a:sym typeface="Roboto"/>
-              </a:rPr>
-              <a:t>#</a:t>
-            </a:r>
-            <a:r>
-              <a:rPr lang="en-US" sz="1500" b="1" dirty="0">
-                <a:latin typeface="Roboto"/>
-                <a:ea typeface="Roboto"/>
-                <a:cs typeface="Roboto"/>
-                <a:sym typeface="Roboto"/>
-              </a:rPr>
-              <a:t>RL-202</a:t>
-            </a:r>
-            <a:r>
-              <a:rPr lang="ru-RU" sz="1500" b="1" dirty="0">
-                <a:latin typeface="Roboto"/>
-                <a:ea typeface="Roboto"/>
-                <a:cs typeface="Roboto"/>
-                <a:sym typeface="Roboto"/>
-              </a:rPr>
-              <a:t>4</a:t>
-            </a:r>
-            <a:r>
-              <a:rPr lang="en-US" sz="1500" b="1" dirty="0">
-                <a:latin typeface="Roboto"/>
-                <a:ea typeface="Roboto"/>
-                <a:cs typeface="Roboto"/>
-                <a:sym typeface="Roboto"/>
-              </a:rPr>
-              <a:t>-</a:t>
-            </a:r>
-            <a:r>
-              <a:rPr lang="ru-RU" sz="1500" b="1" dirty="0">
-                <a:latin typeface="Roboto"/>
-                <a:ea typeface="Roboto"/>
-                <a:cs typeface="Roboto"/>
-                <a:sym typeface="Roboto"/>
-              </a:rPr>
-              <a:t>0</a:t>
-            </a:r>
-            <a:r>
-              <a:rPr lang="en-US" sz="1500" b="1" dirty="0">
-                <a:latin typeface="Roboto"/>
-                <a:ea typeface="Roboto"/>
-                <a:cs typeface="Roboto"/>
-                <a:sym typeface="Roboto"/>
-              </a:rPr>
-              <a:t>9</a:t>
+              <a:t>в учебной группе</a:t>
             </a:r>
             <a:endParaRPr sz="1500" dirty="0">
               <a:latin typeface="Roboto"/>

</xml_diff>